<commit_message>
Model ERR_PTR returns; add seeded-bug evaluation on real kernel modules
IS_ERR()/ERR_PTR handling in the path search cuts warnings on real Linux
modules from 115 to 64 with no benchmark change. New 'klg seed' command
reintroduces a known leak into real kernel code and runs detect, confirm and
fix against the unmodified baseline. Real-module runtime re-run, triage,
report sections 4.4-4.6, slides, README and manual updated.
</commit_message>
<xml_diff>
--- a/docs/KernelLeakGuard_Presentation.pptx
+++ b/docs/KernelLeakGuard_Presentation.pptx
@@ -6608,11 +6608,11 @@
           <a:p>
             <a:pPr>
               <a:spcAft>
-                <a:spcPts val="1200"/>
+                <a:spcPts val="1000"/>
               </a:spcAft>
             </a:pPr>
             <a:r>
-              <a:rPr sz="1700">
+              <a:rPr sz="1600">
                 <a:solidFill>
                   <a:srgbClr val="2A78D6"/>
                 </a:solidFill>
@@ -6621,7 +6621,7 @@
               <a:t>•  </a:t>
             </a:r>
             <a:r>
-              <a:rPr sz="1700" b="1">
+              <a:rPr sz="1600" b="1">
                 <a:solidFill>
                   <a:srgbClr val="0B0B0B"/>
                 </a:solidFill>
@@ -6630,23 +6630,23 @@
               <a:t>Static: </a:t>
             </a:r>
             <a:r>
-              <a:rPr sz="1700">
+              <a:rPr sz="1600">
                 <a:solidFill>
                   <a:srgbClr val="52514E"/>
                 </a:solidFill>
                 <a:latin typeface="Segoe UI"/>
               </a:rPr>
-              <a:t>39 hardware-free modules, 6376 functions, 590 allocation sites → 115 warnings</a:t>
+              <a:t>39 modules, 6376 functions, 590 allocation sites → 64 warnings (ERR_PTR modeling cut these from 115)</a:t>
             </a:r>
           </a:p>
           <a:p>
             <a:pPr>
               <a:spcAft>
-                <a:spcPts val="1200"/>
+                <a:spcPts val="1000"/>
               </a:spcAft>
             </a:pPr>
             <a:r>
-              <a:rPr sz="1700">
+              <a:rPr sz="1600">
                 <a:solidFill>
                   <a:srgbClr val="2A78D6"/>
                 </a:solidFill>
@@ -6655,7 +6655,7 @@
               <a:t>•  </a:t>
             </a:r>
             <a:r>
-              <a:rPr sz="1700" b="1">
+              <a:rPr sz="1600" b="1">
                 <a:solidFill>
                   <a:srgbClr val="0B0B0B"/>
                 </a:solidFill>
@@ -6664,23 +6664,23 @@
               <a:t>Runtime (VM): </a:t>
             </a:r>
             <a:r>
-              <a:rPr sz="1700">
+              <a:rPr sz="1600">
                 <a:solidFill>
                   <a:srgbClr val="52514E"/>
                 </a:solidFill>
                 <a:latin typeface="Segoe UI"/>
               </a:rPr>
-              <a:t>15 representative modules, 6156 fault points of module init exercised</a:t>
+              <a:t>15 modules, 6166 fault points of module init exercised</a:t>
             </a:r>
           </a:p>
           <a:p>
             <a:pPr>
               <a:spcAft>
-                <a:spcPts val="1200"/>
+                <a:spcPts val="1000"/>
               </a:spcAft>
             </a:pPr>
             <a:r>
-              <a:rPr sz="1700">
+              <a:rPr sz="1600">
                 <a:solidFill>
                   <a:srgbClr val="2A78D6"/>
                 </a:solidFill>
@@ -6689,7 +6689,7 @@
               <a:t>•  </a:t>
             </a:r>
             <a:r>
-              <a:rPr sz="1700" b="1">
+              <a:rPr sz="1600" b="1">
                 <a:solidFill>
                   <a:srgbClr val="0B0B0B"/>
                 </a:solidFill>
@@ -6698,23 +6698,23 @@
               <a:t>Manual review: </a:t>
             </a:r>
             <a:r>
-              <a:rPr sz="1700">
+              <a:rPr sz="1600">
                 <a:solidFill>
                   <a:srgbClr val="52514E"/>
                 </a:solidFill>
                 <a:latin typeface="Segoe UI"/>
               </a:rPr>
-              <a:t>all 13 high-confidence warnings read in the source are false positives (ERR_PTR returns, error codes in variables, list ownership) — none confirmed at runtime; most are in mount/ioctl code that init-time testing does not reach</a:t>
+              <a:t>the 12 high-confidence warnings read in source are false positives (refcounted lookups, error codes in variables, list ownership); most sit in mount/ioctl code init-time testing does not reach</a:t>
             </a:r>
           </a:p>
           <a:p>
             <a:pPr>
               <a:spcAft>
-                <a:spcPts val="1200"/>
+                <a:spcPts val="1000"/>
               </a:spcAft>
             </a:pPr>
             <a:r>
-              <a:rPr sz="1700">
+              <a:rPr sz="1600">
                 <a:solidFill>
                   <a:srgbClr val="2A78D6"/>
                 </a:solidFill>
@@ -6723,32 +6723,32 @@
               <a:t>•  </a:t>
             </a:r>
             <a:r>
-              <a:rPr sz="1700" b="1">
-                <a:solidFill>
-                  <a:srgbClr val="0B0B0B"/>
-                </a:solidFill>
-                <a:latin typeface="Segoe UI"/>
-              </a:rPr>
-              <a:t>Sweep observation: </a:t>
-            </a:r>
-            <a:r>
-              <a:rPr sz="1700">
+              <a:rPr sz="1600" b="1">
+                <a:solidFill>
+                  <a:srgbClr val="0B0B0B"/>
+                </a:solidFill>
+                <a:latin typeface="Segoe UI"/>
+              </a:rPr>
+              <a:t>Seeded leak: </a:t>
+            </a:r>
+            <a:r>
+              <a:rPr sz="1600">
                 <a:solidFill>
                   <a:srgbClr val="52514E"/>
                 </a:solidFill>
                 <a:latin typeface="Segoe UI"/>
               </a:rPr>
-              <a:t>1 leak report (erofs init: kmem_cache name strings) — root cause under analysis, likely slab error path</a:t>
+              <a:t>removed one release from real brd init code → detected statically and fixed (re-inserted + validated); confirms the loop works on real code</a:t>
             </a:r>
           </a:p>
           <a:p>
             <a:pPr>
               <a:spcAft>
-                <a:spcPts val="1200"/>
+                <a:spcPts val="1000"/>
               </a:spcAft>
             </a:pPr>
             <a:r>
-              <a:rPr sz="1700">
+              <a:rPr sz="1600">
                 <a:solidFill>
                   <a:srgbClr val="2A78D6"/>
                 </a:solidFill>
@@ -6757,32 +6757,32 @@
               <a:t>•  </a:t>
             </a:r>
             <a:r>
-              <a:rPr sz="1700" b="1">
-                <a:solidFill>
-                  <a:srgbClr val="0B0B0B"/>
-                </a:solidFill>
-                <a:latin typeface="Segoe UI"/>
-              </a:rPr>
-              <a:t>Crash found: </a:t>
-            </a:r>
-            <a:r>
-              <a:rPr sz="1700">
+              <a:rPr sz="1600" b="1">
+                <a:solidFill>
+                  <a:srgbClr val="0B0B0B"/>
+                </a:solidFill>
+                <a:latin typeface="Segoe UI"/>
+              </a:rPr>
+              <a:t>Found on real code: </a:t>
+            </a:r>
+            <a:r>
+              <a:rPr sz="1600">
                 <a:solidFill>
                   <a:srgbClr val="52514E"/>
                 </a:solidFill>
                 <a:latin typeface="Segoe UI"/>
               </a:rPr>
-              <a:t>reproducible kernel crash while loading null_blk under allocation failure (bdev_release reads freed module memory) — root cause still to be analysed</a:t>
+              <a:t>reproducible kernel crash loading null_blk under allocation failure; 1 kmemleak report in erofs init</a:t>
             </a:r>
           </a:p>
           <a:p>
             <a:pPr>
               <a:spcAft>
-                <a:spcPts val="1200"/>
+                <a:spcPts val="1000"/>
               </a:spcAft>
             </a:pPr>
             <a:r>
-              <a:rPr sz="1700">
+              <a:rPr sz="1600">
                 <a:solidFill>
                   <a:srgbClr val="2A78D6"/>
                 </a:solidFill>
@@ -6791,7 +6791,7 @@
               <a:t>•  </a:t>
             </a:r>
             <a:r>
-              <a:rPr sz="1700" b="1">
+              <a:rPr sz="1600" b="1">
                 <a:solidFill>
                   <a:srgbClr val="0B0B0B"/>
                 </a:solidFill>
@@ -6800,7 +6800,7 @@
               <a:t>Lesson: </a:t>
             </a:r>
             <a:r>
-              <a:rPr sz="1700">
+              <a:rPr sz="1600">
                 <a:solidFill>
                   <a:srgbClr val="52514E"/>
                 </a:solidFill>
@@ -7638,7 +7638,7 @@
                 </a:solidFill>
                 <a:latin typeface="Segoe UI"/>
               </a:rPr>
-              <a:t>27 ms for 32 modules</a:t>
+              <a:t>13 ms for 32 modules</a:t>
             </a:r>
           </a:p>
           <a:p>

</xml_diff>

<commit_message>
Live kernel demo, VM window, dashboard Live kernel page, fresh benchmark run
- scripts/live_demo.py: narrated demo inside the guest kernel (SLUB leak via
  erofs fault 85, historical bonding leak) and a root shell; --window shows
  the VM's own screen in a QEMU window; module frames symbolised in the guest
- dashboard: Live kernel page streaming the guest console (demo / shell,
  optional VM window, Stop); finished guests are reaped correctly
- benchmark re-run end to end with the final analyser (fresh baselines);
  report shows all repeated runs plus the final one
- manual, report, handoff and generated documents updated
</commit_message>
<xml_diff>
--- a/docs/KernelLeakGuard_Presentation.pptx
+++ b/docs/KernelLeakGuard_Presentation.pptx
@@ -5794,7 +5794,7 @@
                           </a:solidFill>
                           <a:latin typeface="Segoe UI"/>
                         </a:rPr>
-                        <a:t>15</a:t>
+                        <a:t>16</a:t>
                       </a:r>
                     </a:p>
                   </a:txBody>
@@ -5838,7 +5838,7 @@
                           </a:solidFill>
                           <a:latin typeface="Segoe UI"/>
                         </a:rPr>
-                        <a:t>2</a:t>
+                        <a:t>1</a:t>
                       </a:r>
                     </a:p>
                   </a:txBody>
@@ -5882,7 +5882,7 @@
                           </a:solidFill>
                           <a:latin typeface="Segoe UI"/>
                         </a:rPr>
-                        <a:t>0.88</a:t>
+                        <a:t>0.94</a:t>
                       </a:r>
                     </a:p>
                   </a:txBody>
@@ -5928,7 +5928,7 @@
                           </a:solidFill>
                           <a:latin typeface="Segoe UI"/>
                         </a:rPr>
-                        <a:t>13</a:t>
+                        <a:t>14</a:t>
                       </a:r>
                     </a:p>
                   </a:txBody>
@@ -5972,7 +5972,7 @@
                           </a:solidFill>
                           <a:latin typeface="Segoe UI"/>
                         </a:rPr>
-                        <a:t>4</a:t>
+                        <a:t>3</a:t>
                       </a:r>
                     </a:p>
                   </a:txBody>
@@ -6016,7 +6016,7 @@
                           </a:solidFill>
                           <a:latin typeface="Segoe UI"/>
                         </a:rPr>
-                        <a:t>0.77</a:t>
+                        <a:t>0.82</a:t>
                       </a:r>
                     </a:p>
                   </a:txBody>
@@ -7706,7 +7706,7 @@
                 </a:solidFill>
                 <a:latin typeface="Segoe UI"/>
               </a:rPr>
-              <a:t>14 ms for 32 modules</a:t>
+              <a:t>24 ms for 32 modules</a:t>
             </a:r>
           </a:p>
           <a:p>
@@ -7740,7 +7740,7 @@
                 </a:solidFill>
                 <a:latin typeface="Segoe UI"/>
               </a:rPr>
-              <a:t>0 s + 94 s</a:t>
+              <a:t>80 s + 122 s</a:t>
             </a:r>
           </a:p>
           <a:p>
@@ -7774,7 +7774,7 @@
                 </a:solidFill>
                 <a:latin typeface="Segoe UI"/>
               </a:rPr>
-              <a:t>425 executions in total (module-filtered sweep + confirmation) vs 1261 exhaustive</a:t>
+              <a:t>424 executions in total (module-filtered sweep + confirmation) vs 1279 exhaustive</a:t>
             </a:r>
           </a:p>
           <a:p>
@@ -12600,7 +12600,7 @@
                 </a:solidFill>
                 <a:latin typeface="Segoe UI"/>
               </a:rPr>
-              <a:t>a guest boots in ~2 s; both VM runs take about 2 min.</a:t>
+              <a:t>a guest boots in ~2 s; both VM runs take about 5 min.</a:t>
             </a:r>
           </a:p>
         </p:txBody>

</xml_diff>

<commit_message>
Deliverables rewrite, screenshots, study and demo guides, VM screen in browser
- Shorter title; Proposal (11 pp) and Review-I (12 pp) rewritten in plain
  language; final report with screenshots throughout and a live-demo section
- GUIDE.md / Study Guide PDF with diagrams, glossary and code tour
- DEMO.md / Demo Guide PDF, including a tested type-it-yourself sequence
- live_demo.py: VM screen via QEMU VNC + vendored noVNC, shell mode,
  stop a leftover VM before starting, no audio backend, --step option
- dashboard: VM screen embed, query-param navigation, zombie reaping
- scripts: demo_ready.sh, capture_screenshots.py, winshot.ps1,
  build_demo_guide.py
</commit_message>
<xml_diff>
--- a/docs/KernelLeakGuard_Presentation.pptx
+++ b/docs/KernelLeakGuard_Presentation.pptx
@@ -3209,13 +3209,13 @@
           <a:p>
             <a:pPr algn="l"/>
             <a:r>
-              <a:rPr sz="2600" b="0">
+              <a:rPr sz="3000" b="0">
                 <a:solidFill>
                   <a:srgbClr val="52514E"/>
                 </a:solidFill>
                 <a:latin typeface="Segoe UI"/>
               </a:rPr>
-              <a:t>Hybrid Static Analysis and Runtime Verification of Memory Leaks in Linux Kernel Early-Exit Paths</a:t>
+              <a:t>Detecting and Verifying Linux Kernel Memory Leaks</a:t>
             </a:r>
           </a:p>
         </p:txBody>
@@ -8021,8 +8021,8 @@
         </p:nvSpPr>
         <p:spPr>
           <a:xfrm>
-            <a:off x="548640" y="1280160"/>
-            <a:ext cx="5760720" cy="2926080"/>
+            <a:off x="457200" y="1234440"/>
+            <a:ext cx="5120640" cy="2377440"/>
           </a:xfrm>
           <a:prstGeom prst="roundRect">
             <a:avLst>
@@ -8066,8 +8066,8 @@
         </p:nvSpPr>
         <p:spPr>
           <a:xfrm>
-            <a:off x="731520" y="1389888"/>
-            <a:ext cx="5394960" cy="2743200"/>
+            <a:off x="640080" y="1344168"/>
+            <a:ext cx="4754880" cy="2194560"/>
           </a:xfrm>
           <a:prstGeom prst="rect">
             <a:avLst/>
@@ -8082,7 +8082,7 @@
           <a:p>
             <a:pPr algn="l"/>
             <a:r>
-              <a:rPr sz="1600" b="0">
+              <a:rPr sz="1400" b="0">
                 <a:solidFill>
                   <a:srgbClr val="0B0B0B"/>
                 </a:solidFill>
@@ -8094,61 +8094,49 @@
           <a:p>
             <a:pPr algn="l"/>
             <a:r>
-              <a:rPr sz="1600" b="0">
+              <a:rPr sz="1400" b="0">
                 <a:solidFill>
                   <a:srgbClr val="0B0B0B"/>
                 </a:solidFill>
                 <a:latin typeface="Consolas"/>
               </a:rPr>
-              <a:t>python3 -m klg all</a:t>
+              <a:t>bash scripts/demo_ready.sh --open</a:t>
             </a:r>
           </a:p>
           <a:p>
             <a:pPr algn="l"/>
             <a:r>
-              <a:rPr sz="1600" b="0">
+              <a:rPr sz="1400" b="0">
                 <a:solidFill>
                   <a:srgbClr val="0B0B0B"/>
                 </a:solidFill>
                 <a:latin typeface="Consolas"/>
               </a:rPr>
-              <a:t>python3 -m klg show</a:t>
+              <a:t/>
             </a:r>
           </a:p>
           <a:p>
             <a:pPr algn="l"/>
             <a:r>
-              <a:rPr sz="1600" b="0">
+              <a:rPr sz="1400" b="0">
                 <a:solidFill>
                   <a:srgbClr val="0B0B0B"/>
                 </a:solidFill>
                 <a:latin typeface="Consolas"/>
               </a:rPr>
-              <a:t/>
+              <a:t>python3 scripts/live_demo.py --window</a:t>
             </a:r>
           </a:p>
           <a:p>
             <a:pPr algn="l"/>
             <a:r>
-              <a:rPr sz="1600" b="0">
+              <a:rPr sz="1400" b="0">
                 <a:solidFill>
                   <a:srgbClr val="0B0B0B"/>
                 </a:solidFill>
                 <a:latin typeface="Consolas"/>
               </a:rPr>
-              <a:t>.venv/bin/streamlit run dashboard/app.py</a:t>
-            </a:r>
-          </a:p>
-          <a:p>
-            <a:pPr algn="l"/>
-            <a:r>
-              <a:rPr sz="1600" b="0">
-                <a:solidFill>
-                  <a:srgbClr val="0B0B0B"/>
-                </a:solidFill>
-                <a:latin typeface="Consolas"/>
-              </a:rPr>
-              <a:t># → http://localhost:8501</a:t>
+              <a:t>python3 scripts/live_demo.py shell --window</a:t>
             </a:r>
           </a:p>
         </p:txBody>
@@ -8161,8 +8149,8 @@
         </p:nvSpPr>
         <p:spPr>
           <a:xfrm>
-            <a:off x="6583680" y="1371600"/>
-            <a:ext cx="5303520" cy="4572000"/>
+            <a:off x="457200" y="3794760"/>
+            <a:ext cx="5120640" cy="2743200"/>
           </a:xfrm>
           <a:prstGeom prst="rect">
             <a:avLst/>
@@ -8177,11 +8165,11 @@
           <a:p>
             <a:pPr>
               <a:spcAft>
-                <a:spcPts val="1200"/>
+                <a:spcPts val="600"/>
               </a:spcAft>
             </a:pPr>
             <a:r>
-              <a:rPr sz="1700">
+              <a:rPr sz="1400">
                 <a:solidFill>
                   <a:srgbClr val="2A78D6"/>
                 </a:solidFill>
@@ -8190,23 +8178,23 @@
               <a:t>•  </a:t>
             </a:r>
             <a:r>
-              <a:rPr sz="1700">
-                <a:solidFill>
-                  <a:srgbClr val="0B0B0B"/>
-                </a:solidFill>
-                <a:latin typeface="Segoe UI"/>
-              </a:rPr>
-              <a:t>Pipeline: build → analyse → VM sweep → targeted injection → kmemleak → verdicts</a:t>
+              <a:rPr sz="1400">
+                <a:solidFill>
+                  <a:srgbClr val="0B0B0B"/>
+                </a:solidFill>
+                <a:latin typeface="Segoe UI"/>
+              </a:rPr>
+              <a:t>VM screen: our Linux 6.18.55 boots in QEMU, shown in the browser</a:t>
             </a:r>
           </a:p>
           <a:p>
             <a:pPr>
               <a:spcAft>
-                <a:spcPts val="1200"/>
+                <a:spcPts val="600"/>
               </a:spcAft>
             </a:pPr>
             <a:r>
-              <a:rPr sz="1700">
+              <a:rPr sz="1400">
                 <a:solidFill>
                   <a:srgbClr val="2A78D6"/>
                 </a:solidFill>
@@ -8215,23 +8203,23 @@
               <a:t>•  </a:t>
             </a:r>
             <a:r>
-              <a:rPr sz="1700">
-                <a:solidFill>
-                  <a:srgbClr val="0B0B0B"/>
-                </a:solidFill>
-                <a:latin typeface="Segoe UI"/>
-              </a:rPr>
-              <a:t>Dashboard: findings with verdicts; source with allocation / failing call / exit highlighted; kmemleak backtraces; evaluation charts</a:t>
+              <a:rPr sz="1400">
+                <a:solidFill>
+                  <a:srgbClr val="0B0B0B"/>
+                </a:solidFill>
+                <a:latin typeface="Segoe UI"/>
+              </a:rPr>
+              <a:t>erofs loads cleanly; one allocation failed (fault 85); kmemleak reports the leaked slab cache; the kernel warns (SLUB bug)</a:t>
             </a:r>
           </a:p>
           <a:p>
             <a:pPr>
               <a:spcAft>
-                <a:spcPts val="1200"/>
+                <a:spcPts val="600"/>
               </a:spcAft>
             </a:pPr>
             <a:r>
-              <a:rPr sz="1700">
+              <a:rPr sz="1400">
                 <a:solidFill>
                   <a:srgbClr val="2A78D6"/>
                 </a:solidFill>
@@ -8240,17 +8228,66 @@
               <a:t>•  </a:t>
             </a:r>
             <a:r>
-              <a:rPr sz="1700">
-                <a:solidFill>
-                  <a:srgbClr val="0B0B0B"/>
-                </a:solidFill>
-                <a:latin typeface="Segoe UI"/>
-              </a:rPr>
-              <a:t>Live: introduce a bug in a module, rerun, watch it get confirmed</a:t>
-            </a:r>
-          </a:p>
-        </p:txBody>
-      </p:sp>
+              <a:rPr sz="1400">
+                <a:solidFill>
+                  <a:srgbClr val="0B0B0B"/>
+                </a:solidFill>
+                <a:latin typeface="Segoe UI"/>
+              </a:rPr>
+              <a:t>The 2010 bonding bug: kmemleak reports the leaked net_device</a:t>
+            </a:r>
+          </a:p>
+          <a:p>
+            <a:pPr>
+              <a:spcAft>
+                <a:spcPts val="600"/>
+              </a:spcAft>
+            </a:pPr>
+            <a:r>
+              <a:rPr sz="1400">
+                <a:solidFill>
+                  <a:srgbClr val="2A78D6"/>
+                </a:solidFill>
+                <a:latin typeface="Segoe UI"/>
+              </a:rPr>
+              <a:t>•  </a:t>
+            </a:r>
+            <a:r>
+              <a:rPr sz="1400">
+                <a:solidFill>
+                  <a:srgbClr val="0B0B0B"/>
+                </a:solidFill>
+                <a:latin typeface="Segoe UI"/>
+              </a:rPr>
+              <a:t>Dashboard: findings, evaluation, real-kernel root causes, Live kernel page</a:t>
+            </a:r>
+          </a:p>
+        </p:txBody>
+      </p:sp>
+      <p:pic>
+        <p:nvPicPr>
+          <p:cNvPr id="9" name="Picture 8" descr="ss_vm_step4_kmemleak.png"/>
+          <p:cNvPicPr>
+            <a:picLocks noChangeAspect="1"/>
+          </p:cNvPicPr>
+          <p:nvPr/>
+        </p:nvPicPr>
+        <p:blipFill>
+          <a:blip r:embed="rId2"/>
+          <a:stretch>
+            <a:fillRect/>
+          </a:stretch>
+        </p:blipFill>
+        <p:spPr>
+          <a:xfrm>
+            <a:off x="5852160" y="1234440"/>
+            <a:ext cx="6035040" cy="3352800"/>
+          </a:xfrm>
+          <a:prstGeom prst="rect">
+            <a:avLst/>
+          </a:prstGeom>
+        </p:spPr>
+      </p:pic>
     </p:spTree>
   </p:cSld>
   <p:clrMapOvr>

</xml_diff>